<commit_message>
Mitra: Penambahan gitignore tidak bisa akses ektensi foto
</commit_message>
<xml_diff>
--- a/Improvement/HEAD-OFFICE/QCP LaSak/QCP_LaSak_SurveyDiv HO.pptx
+++ b/Improvement/HEAD-OFFICE/QCP LaSak/QCP_LaSak_SurveyDiv HO.pptx
@@ -5,7 +5,7 @@
     <p:sldMasterId id="2147483648" r:id="rId1"/>
   </p:sldMasterIdLst>
   <p:handoutMasterIdLst>
-    <p:handoutMasterId r:id="rId9"/>
+    <p:handoutMasterId r:id="rId10"/>
   </p:handoutMasterIdLst>
   <p:sldIdLst>
     <p:sldId id="262" r:id="rId2"/>
@@ -14,7 +14,8 @@
     <p:sldId id="270" r:id="rId5"/>
     <p:sldId id="276" r:id="rId6"/>
     <p:sldId id="277" r:id="rId7"/>
-    <p:sldId id="263" r:id="rId8"/>
+    <p:sldId id="278" r:id="rId8"/>
+    <p:sldId id="263" r:id="rId9"/>
   </p:sldIdLst>
   <p:sldSz cx="12192000" cy="6858000"/>
   <p:notesSz cx="6858000" cy="9144000"/>
@@ -218,7 +219,7 @@
           <a:p>
             <a:fld id="{1A61F35B-5A85-4588-9AA9-A3035B93CC37}" type="datetimeFigureOut">
               <a:rPr lang="en-ID" smtClean="0"/>
-              <a:t>08/04/2026</a:t>
+              <a:t>09/04/2026</a:t>
             </a:fld>
             <a:endParaRPr lang="en-ID"/>
           </a:p>
@@ -9904,6 +9905,42 @@
 <file path=ppt/slides/slide7.xml><?xml version="1.0" encoding="utf-8"?>
 <p:sld xmlns:a="http://schemas.openxmlformats.org/drawingml/2006/main" xmlns:r="http://schemas.openxmlformats.org/officeDocument/2006/relationships" xmlns:p="http://schemas.openxmlformats.org/presentationml/2006/main">
   <p:cSld>
+    <p:spTree>
+      <p:nvGrpSpPr>
+        <p:cNvPr id="1" name="">
+          <a:extLst>
+            <a:ext uri="{FF2B5EF4-FFF2-40B4-BE49-F238E27FC236}">
+              <a16:creationId xmlns:a16="http://schemas.microsoft.com/office/drawing/2014/main" id="{72278618-21D2-1BB9-7BB4-34F7BF7CD251}"/>
+            </a:ext>
+          </a:extLst>
+        </p:cNvPr>
+        <p:cNvGrpSpPr/>
+        <p:nvPr/>
+      </p:nvGrpSpPr>
+      <p:grpSpPr>
+        <a:xfrm>
+          <a:off x="0" y="0"/>
+          <a:ext cx="0" cy="0"/>
+          <a:chOff x="0" y="0"/>
+          <a:chExt cx="0" cy="0"/>
+        </a:xfrm>
+      </p:grpSpPr>
+    </p:spTree>
+    <p:extLst>
+      <p:ext uri="{BB962C8B-B14F-4D97-AF65-F5344CB8AC3E}">
+        <p14:creationId xmlns:p14="http://schemas.microsoft.com/office/powerpoint/2010/main" val="234269187"/>
+      </p:ext>
+    </p:extLst>
+  </p:cSld>
+  <p:clrMapOvr>
+    <a:masterClrMapping/>
+  </p:clrMapOvr>
+</p:sld>
+</file>
+
+<file path=ppt/slides/slide8.xml><?xml version="1.0" encoding="utf-8"?>
+<p:sld xmlns:a="http://schemas.openxmlformats.org/drawingml/2006/main" xmlns:r="http://schemas.openxmlformats.org/officeDocument/2006/relationships" xmlns:p="http://schemas.openxmlformats.org/presentationml/2006/main">
+  <p:cSld>
     <p:bg>
       <p:bgPr>
         <a:blipFill dpi="0" rotWithShape="1">

</xml_diff>